<commit_message>
Add team details (IIIT Lucknow) to deck and docs
Co-Authored-By: Claude Opus 5.5 <noreply@anthropic.com>
</commit_message>
<xml_diff>
--- a/presentation/ActionGuard_Final_Presentation.pptx
+++ b/presentation/ActionGuard_Final_Presentation.pptx
@@ -133,13 +133,13 @@
   <p:extLst>
     <p:ext uri="{521415D9-36F7-43E2-AB2F-B90AF26B5E84}">
       <p14:sectionLst xmlns:p14="http://schemas.microsoft.com/office/powerpoint/2010/main">
-        <p14:section name="Opening" id="{fcaa844d-8c30-da00-d262-8eb72912ed96}">
+        <p14:section name="Opening" id="{05dd8cc2-4677-10aa-bf0d-213244a137cb}">
           <p14:sldIdLst>
             <p14:sldId id="256"/>
             <p14:sldId id="257"/>
           </p14:sldIdLst>
         </p14:section>
-        <p14:section name="The problem" id="{a7f31d34-25d1-96b2-46ea-a612b009b6d6}">
+        <p14:section name="The problem" id="{88049d79-506f-c398-c027-f381ee5d6507}">
           <p14:sldIdLst>
             <p14:sldId id="258"/>
             <p14:sldId id="259"/>
@@ -147,7 +147,7 @@
             <p14:sldId id="261"/>
           </p14:sldIdLst>
         </p14:section>
-        <p14:section name="Our solution" id="{da48341d-57c5-d67a-6458-c8b3a315e697}">
+        <p14:section name="Our solution" id="{3ab4dd54-2f02-2a4b-7681-2453664eaa3d}">
           <p14:sldIdLst>
             <p14:sldId id="262"/>
             <p14:sldId id="263"/>
@@ -157,7 +157,7 @@
             <p14:sldId id="267"/>
           </p14:sldIdLst>
         </p14:section>
-        <p14:section name="Implementation" id="{aa13321b-0ad5-dd0d-32d7-d3eeb10c9e4a}">
+        <p14:section name="Implementation" id="{741576aa-4722-90a3-e2e3-a16877c38b94}">
           <p14:sldIdLst>
             <p14:sldId id="268"/>
             <p14:sldId id="269"/>
@@ -166,13 +166,13 @@
             <p14:sldId id="272"/>
           </p14:sldIdLst>
         </p14:section>
-        <p14:section name="Evaluation" id="{4e823986-7174-aeae-0cd2-6cb37b81e656}">
+        <p14:section name="Evaluation" id="{1b9e0d2a-83e2-3808-45b7-3f3c2ff8817d}">
           <p14:sldIdLst>
             <p14:sldId id="273"/>
             <p14:sldId id="274"/>
           </p14:sldIdLst>
         </p14:section>
-        <p14:section name="Market and business" id="{65c1a2c6-291b-3b4e-6b5d-7e560b24052b}">
+        <p14:section name="Market and business" id="{b981b96e-785f-2f48-6de9-a1b7753c5c20}">
           <p14:sldIdLst>
             <p14:sldId id="275"/>
             <p14:sldId id="276"/>
@@ -180,7 +180,7 @@
             <p14:sldId id="278"/>
           </p14:sldIdLst>
         </p14:section>
-        <p14:section name="Wrap-up" id="{2bf8858b-9c11-4240-9c4d-ccec3b9e76a7}">
+        <p14:section name="Wrap-up" id="{049613ec-1631-e97d-4750-ec075ab0b63f}">
           <p14:sldIdLst>
             <p14:sldId id="279"/>
             <p14:sldId id="280"/>
@@ -5218,8 +5218,8 @@
         </p:nvSpPr>
         <p:spPr>
           <a:xfrm>
-            <a:off x="548640" y="4526280"/>
-            <a:ext cx="6217920" cy="1463040"/>
+            <a:off x="548640" y="4297680"/>
+            <a:ext cx="6217920" cy="2148840"/>
           </a:xfrm>
           <a:prstGeom prst="rect">
             <a:avLst/>
@@ -5233,70 +5233,191 @@
           <a:p>
             <a:pPr indent="0" marL="0">
               <a:spcAft>
-                <a:spcPts val="400"/>
+                <a:spcPts val="200"/>
               </a:spcAft>
               <a:buNone/>
             </a:pPr>
             <a:r>
-              <a:rPr lang="en-US" sz="1800" b="1" dirty="0">
+              <a:rPr lang="en-US" sz="1300" b="1" dirty="0">
                 <a:solidFill>
                   <a:schemeClr val="bg1"/>
                 </a:solidFill>
               </a:rPr>
-              <a:t>&lt;Student Name(s)&gt; · &lt;Roll No.&gt;</a:t>
-            </a:r>
-            <a:endParaRPr lang="en-US" sz="1800" dirty="0"/>
-          </a:p>
-          <a:p>
+              <a:t>Prashant Kumar Yadav</a:t>
+            </a:r>
             <a:pPr indent="0" marL="0">
               <a:spcAft>
-                <a:spcPts val="400"/>
+                <a:spcPts val="200"/>
               </a:spcAft>
               <a:buNone/>
             </a:pPr>
             <a:r>
-              <a:rPr lang="en-US" sz="1600" dirty="0">
+              <a:rPr lang="en-US" sz="1200" dirty="0">
                 <a:solidFill>
                   <a:srgbClr val="C9D1DB"/>
                 </a:solidFill>
               </a:rPr>
-              <a:t>Guide: &lt;Guide Name&gt;</a:t>
-            </a:r>
-            <a:endParaRPr lang="en-US" sz="1800" dirty="0"/>
+              <a:t>  LCI2023025 · CSAI</a:t>
+            </a:r>
+            <a:endParaRPr lang="en-US" sz="1300" dirty="0"/>
           </a:p>
           <a:p>
             <a:pPr indent="0" marL="0">
               <a:spcAft>
-                <a:spcPts val="400"/>
+                <a:spcPts val="200"/>
               </a:spcAft>
               <a:buNone/>
             </a:pPr>
             <a:r>
-              <a:rPr lang="en-US" sz="1600" dirty="0">
+              <a:rPr lang="en-US" sz="1300" b="1" dirty="0">
+                <a:solidFill>
+                  <a:schemeClr val="bg1"/>
+                </a:solidFill>
+              </a:rPr>
+              <a:t>Dishant Garg</a:t>
+            </a:r>
+            <a:pPr indent="0" marL="0">
+              <a:spcAft>
+                <a:spcPts val="200"/>
+              </a:spcAft>
+              <a:buNone/>
+            </a:pPr>
+            <a:r>
+              <a:rPr lang="en-US" sz="1200" dirty="0">
                 <a:solidFill>
                   <a:srgbClr val="C9D1DB"/>
                 </a:solidFill>
               </a:rPr>
-              <a:t>&lt;Department, College&gt;</a:t>
-            </a:r>
-            <a:endParaRPr lang="en-US" sz="1800" dirty="0"/>
+              <a:t>  LCB2023011 · CSB</a:t>
+            </a:r>
+            <a:endParaRPr lang="en-US" sz="1300" dirty="0"/>
           </a:p>
           <a:p>
             <a:pPr indent="0" marL="0">
               <a:spcAft>
-                <a:spcPts val="400"/>
+                <a:spcPts val="200"/>
               </a:spcAft>
               <a:buNone/>
             </a:pPr>
             <a:r>
-              <a:rPr lang="en-US" sz="1400" dirty="0">
+              <a:rPr lang="en-US" sz="1300" b="1" dirty="0">
+                <a:solidFill>
+                  <a:schemeClr val="bg1"/>
+                </a:solidFill>
+              </a:rPr>
+              <a:t>Gagan Mishra</a:t>
+            </a:r>
+            <a:pPr indent="0" marL="0">
+              <a:spcAft>
+                <a:spcPts val="200"/>
+              </a:spcAft>
+              <a:buNone/>
+            </a:pPr>
+            <a:r>
+              <a:rPr lang="en-US" sz="1200" dirty="0">
+                <a:solidFill>
+                  <a:srgbClr val="C9D1DB"/>
+                </a:solidFill>
+              </a:rPr>
+              <a:t>  LCI2023038 · CSAI</a:t>
+            </a:r>
+            <a:endParaRPr lang="en-US" sz="1300" dirty="0"/>
+          </a:p>
+          <a:p>
+            <a:pPr indent="0" marL="0">
+              <a:spcAft>
+                <a:spcPts val="200"/>
+              </a:spcAft>
+              <a:buNone/>
+            </a:pPr>
+            <a:r>
+              <a:rPr lang="en-US" sz="1300" b="1" dirty="0">
+                <a:solidFill>
+                  <a:schemeClr val="bg1"/>
+                </a:solidFill>
+              </a:rPr>
+              <a:t>Gaurav Ghodinde</a:t>
+            </a:r>
+            <a:pPr indent="0" marL="0">
+              <a:spcAft>
+                <a:spcPts val="200"/>
+              </a:spcAft>
+              <a:buNone/>
+            </a:pPr>
+            <a:r>
+              <a:rPr lang="en-US" sz="1200" dirty="0">
+                <a:solidFill>
+                  <a:srgbClr val="C9D1DB"/>
+                </a:solidFill>
+              </a:rPr>
+              <a:t>  LCB2023032 · CSB</a:t>
+            </a:r>
+            <a:endParaRPr lang="en-US" sz="1300" dirty="0"/>
+          </a:p>
+          <a:p>
+            <a:pPr indent="0" marL="0">
+              <a:spcAft>
+                <a:spcPts val="200"/>
+              </a:spcAft>
+              <a:buNone/>
+            </a:pPr>
+            <a:r>
+              <a:rPr lang="en-US" sz="1300" b="1" dirty="0">
+                <a:solidFill>
+                  <a:schemeClr val="bg1"/>
+                </a:solidFill>
+              </a:rPr>
+              <a:t>Pranay Naman Buradkar</a:t>
+            </a:r>
+            <a:pPr indent="0" marL="0">
+              <a:spcAft>
+                <a:spcPts val="200"/>
+              </a:spcAft>
+              <a:buNone/>
+            </a:pPr>
+            <a:r>
+              <a:rPr lang="en-US" sz="1200" dirty="0">
+                <a:solidFill>
+                  <a:srgbClr val="C9D1DB"/>
+                </a:solidFill>
+              </a:rPr>
+              <a:t>  LIT2023027 · IT</a:t>
+            </a:r>
+            <a:endParaRPr lang="en-US" sz="1300" dirty="0"/>
+          </a:p>
+          <a:p>
+            <a:pPr indent="0" marL="0">
+              <a:spcAft>
+                <a:spcPts val="200"/>
+              </a:spcAft>
+              <a:buNone/>
+            </a:pPr>
+            <a:r>
+              <a:rPr lang="en-US" sz="1300" dirty="0">
+                <a:solidFill>
+                  <a:srgbClr val="C9D1DB"/>
+                </a:solidFill>
+              </a:rPr>
+              <a:t>Guide: &lt;Guide Name&gt;  ·  IIIT Lucknow</a:t>
+            </a:r>
+            <a:endParaRPr lang="en-US" sz="1300" dirty="0"/>
+          </a:p>
+          <a:p>
+            <a:pPr indent="0" marL="0">
+              <a:spcAft>
+                <a:spcPts val="200"/>
+              </a:spcAft>
+              <a:buNone/>
+            </a:pPr>
+            <a:r>
+              <a:rPr lang="en-US" sz="1200" dirty="0">
                 <a:solidFill>
                   <a:schemeClr val="accent1"/>
                 </a:solidFill>
               </a:rPr>
               <a:t>Final Year Project Review · 2026</a:t>
             </a:r>
-            <a:endParaRPr lang="en-US" sz="1800" dirty="0"/>
+            <a:endParaRPr lang="en-US" sz="1300" dirty="0"/>
           </a:p>
         </p:txBody>
       </p:sp>
@@ -29268,7 +29389,7 @@
                   <a:srgbClr val="C9D1DB"/>
                 </a:solidFill>
               </a:rPr>
-              <a:t>&lt;Student Name(s)&gt; · Guide: &lt;Guide Name&gt;</a:t>
+              <a:t>Team ActionGuard · IIIT Lucknow</a:t>
             </a:r>
             <a:endParaRPr lang="en-US" sz="1600" dirty="0"/>
           </a:p>

</xml_diff>